<commit_message>
Informativa: L_USA_0 modelo combinado WIRP+Taylor como primera slide USA
Nueva slide (modelo_combinado.py) que abre el bloque USA con el backtest
2010-2024 (180 cortes mensuales, horizonte 6m) demostrando por qué se
combina:
  - Panel 1: serie temporal predict A, B, M vs realized + sombreado
    régimen MOVIMIENTO.
  - Panel 2: MAE mediano por régimen (A=16 vs B=34 vs M=17 vs naive=27
    en MOVIMIENTO; naive gana solo en CALMA).
  - Panel 3: distribución de errores absolutos (Mercantil tiene cola
    derecha más controlada).
  - Panel 4: ranking — Mercantil es el peor en SOLO 7% de cortes vs
    46% A y 47% B. Mejor que el peor en 93%.

Mensaje central honesto: combinar no garantiza ser siempre el mejor,
garantiza casi nunca ser el peor. Esa es la robustez que justifica los
pesos 55%/45% calibrados.

Deck actualizado: L_USA_0 ahora es la primera slide después de la
sección USA, antes de L_USA_1 dotplot.
</commit_message>
<xml_diff>
--- a/docs/informativa/outputs/2026-05-30/deck_informativa_2026-05-30.pptx
+++ b/docs/informativa/outputs/2026-05-30/deck_informativa_2026-05-30.pptx
@@ -17,6 +17,7 @@
     <p:sldId id="265" r:id="rId16"/>
     <p:sldId id="266" r:id="rId17"/>
     <p:sldId id="267" r:id="rId18"/>
+    <p:sldId id="268" r:id="rId19"/>
   </p:sldIdLst>
   <p:sldSz cx="12188952" cy="6858000" type="screen4x3"/>
   <p:notesSz cx="6858000" cy="9144000"/>
@@ -3298,14 +3299,57 @@
       <p:grpSpPr/>
       <p:sp>
         <p:nvSpPr>
-          <p:cNvPr id="2" name="TextBox 1"/>
+          <p:cNvPr id="2" name="Rectangle 1"/>
+          <p:cNvSpPr/>
+          <p:nvPr/>
+        </p:nvSpPr>
+        <p:spPr>
+          <a:xfrm>
+            <a:off x="0" y="0"/>
+            <a:ext cx="12188952" cy="6858000"/>
+          </a:xfrm>
+          <a:prstGeom prst="rect">
+            <a:avLst/>
+          </a:prstGeom>
+          <a:solidFill>
+            <a:srgbClr val="1A3A5C"/>
+          </a:solidFill>
+          <a:ln>
+            <a:noFill/>
+          </a:ln>
+        </p:spPr>
+        <p:style>
+          <a:lnRef idx="1">
+            <a:schemeClr val="accent1"/>
+          </a:lnRef>
+          <a:fillRef idx="3">
+            <a:schemeClr val="accent1"/>
+          </a:fillRef>
+          <a:effectRef idx="2">
+            <a:schemeClr val="accent1"/>
+          </a:effectRef>
+          <a:fontRef idx="minor">
+            <a:schemeClr val="lt1"/>
+          </a:fontRef>
+        </p:style>
+        <p:txBody>
+          <a:bodyPr rtlCol="0" anchor="ctr"/>
+          <a:lstStyle/>
+          <a:p>
+            <a:pPr algn="ctr"/>
+          </a:p>
+        </p:txBody>
+      </p:sp>
+      <p:sp>
+        <p:nvSpPr>
+          <p:cNvPr id="3" name="TextBox 2"/>
           <p:cNvSpPr txBox="1"/>
           <p:nvPr/>
         </p:nvSpPr>
         <p:spPr>
           <a:xfrm>
-            <a:off x="365760" y="109728"/>
-            <a:ext cx="11457432" cy="365760"/>
+            <a:off x="731520" y="2651760"/>
+            <a:ext cx="10725912" cy="1005840"/>
           </a:xfrm>
           <a:prstGeom prst="rect">
             <a:avLst/>
@@ -3320,40 +3364,16 @@
           <a:p>
             <a:pPr algn="l"/>
             <a:r>
-              <a:rPr sz="1400" b="1" i="0">
+              <a:rPr sz="3200" b="1" i="0">
                 <a:solidFill>
-                  <a:srgbClr val="1A3A5C"/>
+                  <a:srgbClr val="FFFFFF"/>
                 </a:solidFill>
               </a:rPr>
-              <a:t>Panamá corp · sector × plazo  ·  corte 2026-05-30</a:t>
-            </a:r>
-          </a:p>
-        </p:txBody>
-      </p:sp>
-      <p:pic>
-        <p:nvPicPr>
-          <p:cNvPr id="3" name="Picture 2" descr="L_PA_1_corp_sector_plazo.png"/>
-          <p:cNvPicPr>
-            <a:picLocks noChangeAspect="1"/>
-          </p:cNvPicPr>
-          <p:nvPr/>
-        </p:nvPicPr>
-        <p:blipFill>
-          <a:blip r:embed="rId2"/>
-          <a:stretch>
-            <a:fillRect/>
-          </a:stretch>
-        </p:blipFill>
-        <p:spPr>
-          <a:xfrm>
-            <a:off x="365760" y="548640"/>
-            <a:ext cx="11457432" cy="9306213"/>
-          </a:xfrm>
-          <a:prstGeom prst="rect">
-            <a:avLst/>
-          </a:prstGeom>
-        </p:spPr>
-      </p:pic>
+              <a:t>Bloque Panamá</a:t>
+            </a:r>
+          </a:p>
+        </p:txBody>
+      </p:sp>
       <p:sp>
         <p:nvSpPr>
           <p:cNvPr id="4" name="TextBox 3"/>
@@ -3362,8 +3382,8 @@
         </p:nvSpPr>
         <p:spPr>
           <a:xfrm>
-            <a:off x="365760" y="6537960"/>
-            <a:ext cx="11457432" cy="274320"/>
+            <a:off x="731520" y="3657600"/>
+            <a:ext cx="10725912" cy="1097280"/>
           </a:xfrm>
           <a:prstGeom prst="rect">
             <a:avLst/>
@@ -3378,12 +3398,12 @@
           <a:p>
             <a:pPr algn="l"/>
             <a:r>
-              <a:rPr sz="800" b="0" i="1">
+              <a:rPr sz="1700" b="0" i="0">
                 <a:solidFill>
-                  <a:srgbClr val="666666"/>
+                  <a:srgbClr val="E8EFF7"/>
                 </a:solidFill>
               </a:rPr>
-              <a:t>Documento informativo con fines analíticos. No constituye recomendación de inversión.</a:t>
+              <a:t>L_PA_1 corp sector × plazo · L_PA_2 soberano + CDS (BBG v0.3)</a:t>
             </a:r>
           </a:p>
         </p:txBody>
@@ -3435,21 +3455,45 @@
                   <a:srgbClr val="1A3A5C"/>
                 </a:solidFill>
               </a:rPr>
-              <a:t>Panamá soberano · spread + EMBI + CDS  ·  corte 2026-05-30</a:t>
-            </a:r>
-          </a:p>
-        </p:txBody>
-      </p:sp>
-      <p:sp>
-        <p:nvSpPr>
-          <p:cNvPr id="3" name="TextBox 2"/>
+              <a:t>Panamá corp · sector × plazo  ·  corte 2026-05-30</a:t>
+            </a:r>
+          </a:p>
+        </p:txBody>
+      </p:sp>
+      <p:pic>
+        <p:nvPicPr>
+          <p:cNvPr id="3" name="Picture 2" descr="L_PA_1_corp_sector_plazo.png"/>
+          <p:cNvPicPr>
+            <a:picLocks noChangeAspect="1"/>
+          </p:cNvPicPr>
+          <p:nvPr/>
+        </p:nvPicPr>
+        <p:blipFill>
+          <a:blip r:embed="rId2"/>
+          <a:stretch>
+            <a:fillRect/>
+          </a:stretch>
+        </p:blipFill>
+        <p:spPr>
+          <a:xfrm>
+            <a:off x="365760" y="548640"/>
+            <a:ext cx="11457432" cy="9306213"/>
+          </a:xfrm>
+          <a:prstGeom prst="rect">
+            <a:avLst/>
+          </a:prstGeom>
+        </p:spPr>
+      </p:pic>
+      <p:sp>
+        <p:nvSpPr>
+          <p:cNvPr id="4" name="TextBox 3"/>
           <p:cNvSpPr txBox="1"/>
           <p:nvPr/>
         </p:nvSpPr>
         <p:spPr>
           <a:xfrm>
-            <a:off x="1828800" y="2560320"/>
-            <a:ext cx="8531352" cy="1828800"/>
+            <a:off x="365760" y="6537960"/>
+            <a:ext cx="11457432" cy="274320"/>
           </a:xfrm>
           <a:prstGeom prst="rect">
             <a:avLst/>
@@ -3462,14 +3506,14 @@
           </a:bodyPr>
           <a:lstStyle/>
           <a:p>
-            <a:pPr algn="ctr"/>
-            <a:r>
-              <a:rPr sz="2200" i="1">
+            <a:pPr algn="l"/>
+            <a:r>
+              <a:rPr sz="800" b="0" i="1">
                 <a:solidFill>
                   <a:srgbClr val="666666"/>
                 </a:solidFill>
               </a:rPr>
-              <a:t>En construcción · Sprint 3.2 · pendiente plantilla BBG v0.3</a:t>
+              <a:t>Documento informativo con fines analíticos. No constituye recomendación de inversión.</a:t>
             </a:r>
           </a:p>
         </p:txBody>
@@ -3494,6 +3538,92 @@
       <p:grpSpPr/>
       <p:sp>
         <p:nvSpPr>
+          <p:cNvPr id="2" name="TextBox 1"/>
+          <p:cNvSpPr txBox="1"/>
+          <p:nvPr/>
+        </p:nvSpPr>
+        <p:spPr>
+          <a:xfrm>
+            <a:off x="365760" y="109728"/>
+            <a:ext cx="11457432" cy="365760"/>
+          </a:xfrm>
+          <a:prstGeom prst="rect">
+            <a:avLst/>
+          </a:prstGeom>
+          <a:noFill/>
+        </p:spPr>
+        <p:txBody>
+          <a:bodyPr wrap="square">
+            <a:spAutoFit/>
+          </a:bodyPr>
+          <a:lstStyle/>
+          <a:p>
+            <a:pPr algn="l"/>
+            <a:r>
+              <a:rPr sz="1400" b="1" i="0">
+                <a:solidFill>
+                  <a:srgbClr val="1A3A5C"/>
+                </a:solidFill>
+              </a:rPr>
+              <a:t>Panamá soberano · spread + EMBI + CDS  ·  corte 2026-05-30</a:t>
+            </a:r>
+          </a:p>
+        </p:txBody>
+      </p:sp>
+      <p:sp>
+        <p:nvSpPr>
+          <p:cNvPr id="3" name="TextBox 2"/>
+          <p:cNvSpPr txBox="1"/>
+          <p:nvPr/>
+        </p:nvSpPr>
+        <p:spPr>
+          <a:xfrm>
+            <a:off x="1828800" y="2560320"/>
+            <a:ext cx="8531352" cy="1828800"/>
+          </a:xfrm>
+          <a:prstGeom prst="rect">
+            <a:avLst/>
+          </a:prstGeom>
+          <a:noFill/>
+        </p:spPr>
+        <p:txBody>
+          <a:bodyPr wrap="square">
+            <a:spAutoFit/>
+          </a:bodyPr>
+          <a:lstStyle/>
+          <a:p>
+            <a:pPr algn="ctr"/>
+            <a:r>
+              <a:rPr sz="2200" i="1">
+                <a:solidFill>
+                  <a:srgbClr val="666666"/>
+                </a:solidFill>
+              </a:rPr>
+              <a:t>En construcción · Sprint 3.2 · pendiente plantilla BBG v0.3</a:t>
+            </a:r>
+          </a:p>
+        </p:txBody>
+      </p:sp>
+    </p:spTree>
+  </p:cSld>
+  <p:clrMapOvr>
+    <a:masterClrMapping/>
+  </p:clrMapOvr>
+</p:sld>
+</file>
+
+<file path=ppt/slides/slide13.xml><?xml version="1.0" encoding="utf-8"?>
+<p:sld xmlns:a="http://schemas.openxmlformats.org/drawingml/2006/main" xmlns:p="http://schemas.openxmlformats.org/presentationml/2006/main" xmlns:r="http://schemas.openxmlformats.org/officeDocument/2006/relationships">
+  <p:cSld>
+    <p:spTree>
+      <p:nvGrpSpPr>
+        <p:cNvPr id="1" name=""/>
+        <p:cNvGrpSpPr/>
+        <p:nvPr/>
+      </p:nvGrpSpPr>
+      <p:grpSpPr/>
+      <p:sp>
+        <p:nvSpPr>
           <p:cNvPr id="2" name="Rectangle 1"/>
           <p:cNvSpPr/>
           <p:nvPr/>
@@ -3727,7 +3857,7 @@
                   <a:srgbClr val="E8EFF7"/>
                 </a:solidFill>
               </a:rPr>
-              <a:t>L_USA_1 dot plot SEP · L_USA_2 path multi-fuente · L_USA_3 estructura temporal</a:t>
+              <a:t>Modelo combinado WIRP+Taylor · dot plot SEP · path multi-fuente · estructura temporal</a:t>
             </a:r>
           </a:p>
         </p:txBody>
@@ -3779,14 +3909,14 @@
                   <a:srgbClr val="1A3A5C"/>
                 </a:solidFill>
               </a:rPr>
-              <a:t>Dot plot Fed — proyecciones SEP  ·  corte 2026-05-30</a:t>
+              <a:t>Por qué combinamos: WIRP + Taylor (backtest 2010-2024)  ·  corte 2026-05-30</a:t>
             </a:r>
           </a:p>
         </p:txBody>
       </p:sp>
       <p:pic>
         <p:nvPicPr>
-          <p:cNvPr id="3" name="Picture 2" descr="L_USA_1_dotplot.png"/>
+          <p:cNvPr id="3" name="Picture 2" descr="L_USA_0_modelo_combinado.png"/>
           <p:cNvPicPr>
             <a:picLocks noChangeAspect="1"/>
           </p:cNvPicPr>
@@ -3801,7 +3931,7 @@
         <p:spPr>
           <a:xfrm>
             <a:off x="365760" y="548640"/>
-            <a:ext cx="11457432" cy="6619567"/>
+            <a:ext cx="11457432" cy="8297726"/>
           </a:xfrm>
           <a:prstGeom prst="rect">
             <a:avLst/>
@@ -3889,14 +4019,14 @@
                   <a:srgbClr val="1A3A5C"/>
                 </a:solidFill>
               </a:rPr>
-              <a:t>Fed Funds: mercado · analistas · sentiment  ·  corte 2026-05-30</a:t>
+              <a:t>Dot plot Fed — proyecciones SEP  ·  corte 2026-05-30</a:t>
             </a:r>
           </a:p>
         </p:txBody>
       </p:sp>
       <p:pic>
         <p:nvPicPr>
-          <p:cNvPr id="3" name="Picture 2" descr="L_USA_2_path_fed.png"/>
+          <p:cNvPr id="3" name="Picture 2" descr="L_USA_1_dotplot.png"/>
           <p:cNvPicPr>
             <a:picLocks noChangeAspect="1"/>
           </p:cNvPicPr>
@@ -3911,7 +4041,7 @@
         <p:spPr>
           <a:xfrm>
             <a:off x="365760" y="548640"/>
-            <a:ext cx="11457432" cy="7522251"/>
+            <a:ext cx="11457432" cy="6619567"/>
           </a:xfrm>
           <a:prstGeom prst="rect">
             <a:avLst/>
@@ -3999,14 +4129,14 @@
                   <a:srgbClr val="1A3A5C"/>
                 </a:solidFill>
               </a:rPr>
-              <a:t>Estructura temporal de tasas USA  ·  corte 2026-05-30</a:t>
+              <a:t>Fed Funds: mercado · analistas · sentiment  ·  corte 2026-05-30</a:t>
             </a:r>
           </a:p>
         </p:txBody>
       </p:sp>
       <p:pic>
         <p:nvPicPr>
-          <p:cNvPr id="3" name="Picture 2" descr="L_USA_3_curvas_usa.png"/>
+          <p:cNvPr id="3" name="Picture 2" descr="L_USA_2_path_fed.png"/>
           <p:cNvPicPr>
             <a:picLocks noChangeAspect="1"/>
           </p:cNvPicPr>
@@ -4021,7 +4151,7 @@
         <p:spPr>
           <a:xfrm>
             <a:off x="365760" y="548640"/>
-            <a:ext cx="11457432" cy="7122016"/>
+            <a:ext cx="11457432" cy="7522251"/>
           </a:xfrm>
           <a:prstGeom prst="rect">
             <a:avLst/>
@@ -4082,57 +4212,14 @@
       <p:grpSpPr/>
       <p:sp>
         <p:nvSpPr>
-          <p:cNvPr id="2" name="Rectangle 1"/>
-          <p:cNvSpPr/>
-          <p:nvPr/>
-        </p:nvSpPr>
-        <p:spPr>
-          <a:xfrm>
-            <a:off x="0" y="0"/>
-            <a:ext cx="12188952" cy="6858000"/>
-          </a:xfrm>
-          <a:prstGeom prst="rect">
-            <a:avLst/>
-          </a:prstGeom>
-          <a:solidFill>
-            <a:srgbClr val="1A3A5C"/>
-          </a:solidFill>
-          <a:ln>
-            <a:noFill/>
-          </a:ln>
-        </p:spPr>
-        <p:style>
-          <a:lnRef idx="1">
-            <a:schemeClr val="accent1"/>
-          </a:lnRef>
-          <a:fillRef idx="3">
-            <a:schemeClr val="accent1"/>
-          </a:fillRef>
-          <a:effectRef idx="2">
-            <a:schemeClr val="accent1"/>
-          </a:effectRef>
-          <a:fontRef idx="minor">
-            <a:schemeClr val="lt1"/>
-          </a:fontRef>
-        </p:style>
-        <p:txBody>
-          <a:bodyPr rtlCol="0" anchor="ctr"/>
-          <a:lstStyle/>
-          <a:p>
-            <a:pPr algn="ctr"/>
-          </a:p>
-        </p:txBody>
-      </p:sp>
-      <p:sp>
-        <p:nvSpPr>
-          <p:cNvPr id="3" name="TextBox 2"/>
+          <p:cNvPr id="2" name="TextBox 1"/>
           <p:cNvSpPr txBox="1"/>
           <p:nvPr/>
         </p:nvSpPr>
         <p:spPr>
           <a:xfrm>
-            <a:off x="731520" y="2651760"/>
-            <a:ext cx="10725912" cy="1005840"/>
+            <a:off x="365760" y="109728"/>
+            <a:ext cx="11457432" cy="365760"/>
           </a:xfrm>
           <a:prstGeom prst="rect">
             <a:avLst/>
@@ -4147,16 +4234,40 @@
           <a:p>
             <a:pPr algn="l"/>
             <a:r>
-              <a:rPr sz="3200" b="1" i="0">
+              <a:rPr sz="1400" b="1" i="0">
                 <a:solidFill>
-                  <a:srgbClr val="FFFFFF"/>
+                  <a:srgbClr val="1A3A5C"/>
                 </a:solidFill>
               </a:rPr>
-              <a:t>Bloque FX G10</a:t>
-            </a:r>
-          </a:p>
-        </p:txBody>
-      </p:sp>
+              <a:t>Estructura temporal de tasas USA  ·  corte 2026-05-30</a:t>
+            </a:r>
+          </a:p>
+        </p:txBody>
+      </p:sp>
+      <p:pic>
+        <p:nvPicPr>
+          <p:cNvPr id="3" name="Picture 2" descr="L_USA_3_curvas_usa.png"/>
+          <p:cNvPicPr>
+            <a:picLocks noChangeAspect="1"/>
+          </p:cNvPicPr>
+          <p:nvPr/>
+        </p:nvPicPr>
+        <p:blipFill>
+          <a:blip r:embed="rId2"/>
+          <a:stretch>
+            <a:fillRect/>
+          </a:stretch>
+        </p:blipFill>
+        <p:spPr>
+          <a:xfrm>
+            <a:off x="365760" y="548640"/>
+            <a:ext cx="11457432" cy="7122016"/>
+          </a:xfrm>
+          <a:prstGeom prst="rect">
+            <a:avLst/>
+          </a:prstGeom>
+        </p:spPr>
+      </p:pic>
       <p:sp>
         <p:nvSpPr>
           <p:cNvPr id="4" name="TextBox 3"/>
@@ -4165,8 +4276,8 @@
         </p:nvSpPr>
         <p:spPr>
           <a:xfrm>
-            <a:off x="731520" y="3657600"/>
-            <a:ext cx="10725912" cy="1097280"/>
+            <a:off x="365760" y="6537960"/>
+            <a:ext cx="11457432" cy="274320"/>
           </a:xfrm>
           <a:prstGeom prst="rect">
             <a:avLst/>
@@ -4181,12 +4292,12 @@
           <a:p>
             <a:pPr algn="l"/>
             <a:r>
-              <a:rPr sz="1700" b="0" i="0">
+              <a:rPr sz="800" b="0" i="1">
                 <a:solidFill>
-                  <a:srgbClr val="E8EFF7"/>
+                  <a:srgbClr val="666666"/>
                 </a:solidFill>
               </a:rPr>
-              <a:t>L_FX_1 spots y evolución · L_FX_2 forwards 5y (BBG v0.3)</a:t>
+              <a:t>Documento informativo con fines analíticos. No constituye recomendación de inversión.</a:t>
             </a:r>
           </a:p>
         </p:txBody>
@@ -4211,14 +4322,57 @@
       <p:grpSpPr/>
       <p:sp>
         <p:nvSpPr>
-          <p:cNvPr id="2" name="TextBox 1"/>
+          <p:cNvPr id="2" name="Rectangle 1"/>
+          <p:cNvSpPr/>
+          <p:nvPr/>
+        </p:nvSpPr>
+        <p:spPr>
+          <a:xfrm>
+            <a:off x="0" y="0"/>
+            <a:ext cx="12188952" cy="6858000"/>
+          </a:xfrm>
+          <a:prstGeom prst="rect">
+            <a:avLst/>
+          </a:prstGeom>
+          <a:solidFill>
+            <a:srgbClr val="1A3A5C"/>
+          </a:solidFill>
+          <a:ln>
+            <a:noFill/>
+          </a:ln>
+        </p:spPr>
+        <p:style>
+          <a:lnRef idx="1">
+            <a:schemeClr val="accent1"/>
+          </a:lnRef>
+          <a:fillRef idx="3">
+            <a:schemeClr val="accent1"/>
+          </a:fillRef>
+          <a:effectRef idx="2">
+            <a:schemeClr val="accent1"/>
+          </a:effectRef>
+          <a:fontRef idx="minor">
+            <a:schemeClr val="lt1"/>
+          </a:fontRef>
+        </p:style>
+        <p:txBody>
+          <a:bodyPr rtlCol="0" anchor="ctr"/>
+          <a:lstStyle/>
+          <a:p>
+            <a:pPr algn="ctr"/>
+          </a:p>
+        </p:txBody>
+      </p:sp>
+      <p:sp>
+        <p:nvSpPr>
+          <p:cNvPr id="3" name="TextBox 2"/>
           <p:cNvSpPr txBox="1"/>
           <p:nvPr/>
         </p:nvSpPr>
         <p:spPr>
           <a:xfrm>
-            <a:off x="365760" y="109728"/>
-            <a:ext cx="11457432" cy="365760"/>
+            <a:off x="731520" y="2651760"/>
+            <a:ext cx="10725912" cy="1005840"/>
           </a:xfrm>
           <a:prstGeom prst="rect">
             <a:avLst/>
@@ -4233,40 +4387,16 @@
           <a:p>
             <a:pPr algn="l"/>
             <a:r>
-              <a:rPr sz="1400" b="1" i="0">
+              <a:rPr sz="3200" b="1" i="0">
                 <a:solidFill>
-                  <a:srgbClr val="1A3A5C"/>
+                  <a:srgbClr val="FFFFFF"/>
                 </a:solidFill>
               </a:rPr>
-              <a:t>FX G10 + DXY: spots y evolución  ·  corte 2026-05-30</a:t>
-            </a:r>
-          </a:p>
-        </p:txBody>
-      </p:sp>
-      <p:pic>
-        <p:nvPicPr>
-          <p:cNvPr id="3" name="Picture 2" descr="L_FX_1_g10.png"/>
-          <p:cNvPicPr>
-            <a:picLocks noChangeAspect="1"/>
-          </p:cNvPicPr>
-          <p:nvPr/>
-        </p:nvPicPr>
-        <p:blipFill>
-          <a:blip r:embed="rId2"/>
-          <a:stretch>
-            <a:fillRect/>
-          </a:stretch>
-        </p:blipFill>
-        <p:spPr>
-          <a:xfrm>
-            <a:off x="365760" y="548640"/>
-            <a:ext cx="11457432" cy="7366899"/>
-          </a:xfrm>
-          <a:prstGeom prst="rect">
-            <a:avLst/>
-          </a:prstGeom>
-        </p:spPr>
-      </p:pic>
+              <a:t>Bloque FX G10</a:t>
+            </a:r>
+          </a:p>
+        </p:txBody>
+      </p:sp>
       <p:sp>
         <p:nvSpPr>
           <p:cNvPr id="4" name="TextBox 3"/>
@@ -4275,8 +4405,8 @@
         </p:nvSpPr>
         <p:spPr>
           <a:xfrm>
-            <a:off x="365760" y="6537960"/>
-            <a:ext cx="11457432" cy="274320"/>
+            <a:off x="731520" y="3657600"/>
+            <a:ext cx="10725912" cy="1097280"/>
           </a:xfrm>
           <a:prstGeom prst="rect">
             <a:avLst/>
@@ -4291,12 +4421,12 @@
           <a:p>
             <a:pPr algn="l"/>
             <a:r>
-              <a:rPr sz="800" b="0" i="1">
+              <a:rPr sz="1700" b="0" i="0">
                 <a:solidFill>
-                  <a:srgbClr val="666666"/>
+                  <a:srgbClr val="E8EFF7"/>
                 </a:solidFill>
               </a:rPr>
-              <a:t>Documento informativo con fines analíticos. No constituye recomendación de inversión.</a:t>
+              <a:t>L_FX_1 spots y evolución · L_FX_2 forwards 5y (BBG v0.3)</a:t>
             </a:r>
           </a:p>
         </p:txBody>
@@ -4348,21 +4478,45 @@
                   <a:srgbClr val="1A3A5C"/>
                 </a:solidFill>
               </a:rPr>
-              <a:t>Forwards FX trimestrales 5y  ·  corte 2026-05-30</a:t>
-            </a:r>
-          </a:p>
-        </p:txBody>
-      </p:sp>
-      <p:sp>
-        <p:nvSpPr>
-          <p:cNvPr id="3" name="TextBox 2"/>
+              <a:t>FX G10 + DXY: spots y evolución  ·  corte 2026-05-30</a:t>
+            </a:r>
+          </a:p>
+        </p:txBody>
+      </p:sp>
+      <p:pic>
+        <p:nvPicPr>
+          <p:cNvPr id="3" name="Picture 2" descr="L_FX_1_g10.png"/>
+          <p:cNvPicPr>
+            <a:picLocks noChangeAspect="1"/>
+          </p:cNvPicPr>
+          <p:nvPr/>
+        </p:nvPicPr>
+        <p:blipFill>
+          <a:blip r:embed="rId2"/>
+          <a:stretch>
+            <a:fillRect/>
+          </a:stretch>
+        </p:blipFill>
+        <p:spPr>
+          <a:xfrm>
+            <a:off x="365760" y="548640"/>
+            <a:ext cx="11457432" cy="7366899"/>
+          </a:xfrm>
+          <a:prstGeom prst="rect">
+            <a:avLst/>
+          </a:prstGeom>
+        </p:spPr>
+      </p:pic>
+      <p:sp>
+        <p:nvSpPr>
+          <p:cNvPr id="4" name="TextBox 3"/>
           <p:cNvSpPr txBox="1"/>
           <p:nvPr/>
         </p:nvSpPr>
         <p:spPr>
           <a:xfrm>
-            <a:off x="1828800" y="2560320"/>
-            <a:ext cx="8531352" cy="1828800"/>
+            <a:off x="365760" y="6537960"/>
+            <a:ext cx="11457432" cy="274320"/>
           </a:xfrm>
           <a:prstGeom prst="rect">
             <a:avLst/>
@@ -4375,14 +4529,14 @@
           </a:bodyPr>
           <a:lstStyle/>
           <a:p>
-            <a:pPr algn="ctr"/>
-            <a:r>
-              <a:rPr sz="2200" i="1">
+            <a:pPr algn="l"/>
+            <a:r>
+              <a:rPr sz="800" b="0" i="1">
                 <a:solidFill>
                   <a:srgbClr val="666666"/>
                 </a:solidFill>
               </a:rPr>
-              <a:t>En construcción · Sprint 2.2 · pendiente plantilla BBG v0.3</a:t>
+              <a:t>Documento informativo con fines analíticos. No constituye recomendación de inversión.</a:t>
             </a:r>
           </a:p>
         </p:txBody>
@@ -4407,57 +4561,14 @@
       <p:grpSpPr/>
       <p:sp>
         <p:nvSpPr>
-          <p:cNvPr id="2" name="Rectangle 1"/>
-          <p:cNvSpPr/>
-          <p:nvPr/>
-        </p:nvSpPr>
-        <p:spPr>
-          <a:xfrm>
-            <a:off x="0" y="0"/>
-            <a:ext cx="12188952" cy="6858000"/>
-          </a:xfrm>
-          <a:prstGeom prst="rect">
-            <a:avLst/>
-          </a:prstGeom>
-          <a:solidFill>
-            <a:srgbClr val="1A3A5C"/>
-          </a:solidFill>
-          <a:ln>
-            <a:noFill/>
-          </a:ln>
-        </p:spPr>
-        <p:style>
-          <a:lnRef idx="1">
-            <a:schemeClr val="accent1"/>
-          </a:lnRef>
-          <a:fillRef idx="3">
-            <a:schemeClr val="accent1"/>
-          </a:fillRef>
-          <a:effectRef idx="2">
-            <a:schemeClr val="accent1"/>
-          </a:effectRef>
-          <a:fontRef idx="minor">
-            <a:schemeClr val="lt1"/>
-          </a:fontRef>
-        </p:style>
-        <p:txBody>
-          <a:bodyPr rtlCol="0" anchor="ctr"/>
-          <a:lstStyle/>
-          <a:p>
-            <a:pPr algn="ctr"/>
-          </a:p>
-        </p:txBody>
-      </p:sp>
-      <p:sp>
-        <p:nvSpPr>
-          <p:cNvPr id="3" name="TextBox 2"/>
+          <p:cNvPr id="2" name="TextBox 1"/>
           <p:cNvSpPr txBox="1"/>
           <p:nvPr/>
         </p:nvSpPr>
         <p:spPr>
           <a:xfrm>
-            <a:off x="731520" y="2651760"/>
-            <a:ext cx="10725912" cy="1005840"/>
+            <a:off x="365760" y="109728"/>
+            <a:ext cx="11457432" cy="365760"/>
           </a:xfrm>
           <a:prstGeom prst="rect">
             <a:avLst/>
@@ -4472,26 +4583,26 @@
           <a:p>
             <a:pPr algn="l"/>
             <a:r>
-              <a:rPr sz="3200" b="1" i="0">
+              <a:rPr sz="1400" b="1" i="0">
                 <a:solidFill>
-                  <a:srgbClr val="FFFFFF"/>
+                  <a:srgbClr val="1A3A5C"/>
                 </a:solidFill>
               </a:rPr>
-              <a:t>Bloque Panamá</a:t>
-            </a:r>
-          </a:p>
-        </p:txBody>
-      </p:sp>
-      <p:sp>
-        <p:nvSpPr>
-          <p:cNvPr id="4" name="TextBox 3"/>
+              <a:t>Forwards FX trimestrales 5y  ·  corte 2026-05-30</a:t>
+            </a:r>
+          </a:p>
+        </p:txBody>
+      </p:sp>
+      <p:sp>
+        <p:nvSpPr>
+          <p:cNvPr id="3" name="TextBox 2"/>
           <p:cNvSpPr txBox="1"/>
           <p:nvPr/>
         </p:nvSpPr>
         <p:spPr>
           <a:xfrm>
-            <a:off x="731520" y="3657600"/>
-            <a:ext cx="10725912" cy="1097280"/>
+            <a:off x="1828800" y="2560320"/>
+            <a:ext cx="8531352" cy="1828800"/>
           </a:xfrm>
           <a:prstGeom prst="rect">
             <a:avLst/>
@@ -4504,14 +4615,14 @@
           </a:bodyPr>
           <a:lstStyle/>
           <a:p>
-            <a:pPr algn="l"/>
-            <a:r>
-              <a:rPr sz="1700" b="0" i="0">
+            <a:pPr algn="ctr"/>
+            <a:r>
+              <a:rPr sz="2200" i="1">
                 <a:solidFill>
-                  <a:srgbClr val="E8EFF7"/>
+                  <a:srgbClr val="666666"/>
                 </a:solidFill>
               </a:rPr>
-              <a:t>L_PA_1 corp sector × plazo · L_PA_2 soberano + CDS (BBG v0.3)</a:t>
+              <a:t>En construcción · Sprint 2.2 · pendiente plantilla BBG v0.3</a:t>
             </a:r>
           </a:p>
         </p:txBody>

</xml_diff>